<commit_message>
Rebuild the sample deck and save the test and guard run output beside the README claims
The README says what the figure check does not prove, the run counts point at docs/test-runs/2026-10-25.txt where the suite and guard output is kept verbatim, and the catalogue copy design notes moved to their own page to keep the README under its length cap.
</commit_message>
<xml_diff>
--- a/docs/monthly-report-sample/report_2026-10.pptx
+++ b/docs/monthly-report-sample/report_2026-10.pptx
@@ -146,6 +146,23 @@
           <c:marker>
             <c:symbol val="none"/>
           </c:marker>
+          <c:dPt>
+            <c:idx val="5"/>
+            <c:marker>
+              <c:symbol val="circle"/>
+              <c:size val="9"/>
+              <c:spPr>
+                <a:solidFill>
+                  <a:srgbClr val="1B7F8C"/>
+                </a:solidFill>
+                <a:ln>
+                  <a:solidFill>
+                    <a:srgbClr val="1B7F8C"/>
+                  </a:solidFill>
+                </a:ln>
+              </c:spPr>
+            </c:marker>
+          </c:dPt>
           <c:cat>
             <c:strRef>
               <c:f>Sheet1!$A$2:$A$32</c:f>
@@ -472,99 +489,247 @@
           </c:cat>
           <c:val>
             <c:numRef>
-              <c:f>Sheet1!$C$2:$C$32</c:f>
+              <c:f>Sheet1!$C$2:$C$31</c:f>
+              <c:numCache>
+                <c:formatCode>General</c:formatCode>
+                <c:ptCount val="30"/>
+                <c:pt idx="0">
+                  <c:v>1250.0</c:v>
+                </c:pt>
+                <c:pt idx="1">
+                  <c:v>1390.24</c:v>
+                </c:pt>
+                <c:pt idx="2">
+                  <c:v>1465.96</c:v>
+                </c:pt>
+                <c:pt idx="3">
+                  <c:v>1881.42</c:v>
+                </c:pt>
+                <c:pt idx="4">
+                  <c:v>1838.65</c:v>
+                </c:pt>
+                <c:pt idx="5">
+                  <c:v>1981.97</c:v>
+                </c:pt>
+                <c:pt idx="6">
+                  <c:v>0.0</c:v>
+                </c:pt>
+                <c:pt idx="7">
+                  <c:v>1212.26</c:v>
+                </c:pt>
+                <c:pt idx="8">
+                  <c:v>1047.71</c:v>
+                </c:pt>
+                <c:pt idx="9">
+                  <c:v>1107.8</c:v>
+                </c:pt>
+                <c:pt idx="10">
+                  <c:v>1454.55</c:v>
+                </c:pt>
+                <c:pt idx="11">
+                  <c:v>1891.53</c:v>
+                </c:pt>
+                <c:pt idx="12">
+                  <c:v>2008.74</c:v>
+                </c:pt>
+                <c:pt idx="13">
+                  <c:v>1415.63</c:v>
+                </c:pt>
+                <c:pt idx="14">
+                  <c:v>1253.27</c:v>
+                </c:pt>
+                <c:pt idx="15">
+                  <c:v>1094.08</c:v>
+                </c:pt>
+                <c:pt idx="16">
+                  <c:v>1592.91</c:v>
+                </c:pt>
+                <c:pt idx="17">
+                  <c:v>1839.95</c:v>
+                </c:pt>
+                <c:pt idx="18">
+                  <c:v>1648.79</c:v>
+                </c:pt>
+                <c:pt idx="19">
+                  <c:v>1099.31</c:v>
+                </c:pt>
+                <c:pt idx="20">
+                  <c:v>1295.03</c:v>
+                </c:pt>
+                <c:pt idx="21">
+                  <c:v>0.0</c:v>
+                </c:pt>
+                <c:pt idx="22">
+                  <c:v>1097.83</c:v>
+                </c:pt>
+                <c:pt idx="23">
+                  <c:v>1651.48</c:v>
+                </c:pt>
+                <c:pt idx="24">
+                  <c:v>2077.77</c:v>
+                </c:pt>
+                <c:pt idx="25">
+                  <c:v>1355.29</c:v>
+                </c:pt>
+                <c:pt idx="26">
+                  <c:v>1790.66</c:v>
+                </c:pt>
+                <c:pt idx="27">
+                  <c:v>1082.55</c:v>
+                </c:pt>
+                <c:pt idx="28">
+                  <c:v>1139.63</c:v>
+                </c:pt>
+                <c:pt idx="29">
+                  <c:v>1001.1</c:v>
+                </c:pt>
+              </c:numCache>
+            </c:numRef>
+          </c:val>
+          <c:smooth val="0"/>
+        </c:ser>
+        <c:ser>
+          <c:idx val="2"/>
+          <c:order val="2"/>
+          <c:tx>
+            <c:strRef>
+              <c:f>Sheet1!$D$1</c:f>
+              <c:strCache>
+                <c:ptCount val="1"/>
+                <c:pt idx="0">
+                  <c:v>Day with no data</c:v>
+                </c:pt>
+              </c:strCache>
+            </c:strRef>
+          </c:tx>
+          <c:spPr>
+            <a:ln>
+              <a:noFill/>
+            </a:ln>
+          </c:spPr>
+          <c:marker>
+            <c:symbol val="x"/>
+            <c:size val="10"/>
+            <c:spPr>
+              <a:ln>
+                <a:solidFill>
+                  <a:srgbClr val="B44A1E"/>
+                </a:solidFill>
+              </a:ln>
+            </c:spPr>
+          </c:marker>
+          <c:cat>
+            <c:strRef>
+              <c:f>Sheet1!$A$2:$A$32</c:f>
+              <c:strCache>
+                <c:ptCount val="31"/>
+                <c:pt idx="0">
+                  <c:v>1</c:v>
+                </c:pt>
+                <c:pt idx="1">
+                  <c:v>2</c:v>
+                </c:pt>
+                <c:pt idx="2">
+                  <c:v>3</c:v>
+                </c:pt>
+                <c:pt idx="3">
+                  <c:v>4</c:v>
+                </c:pt>
+                <c:pt idx="4">
+                  <c:v>5</c:v>
+                </c:pt>
+                <c:pt idx="5">
+                  <c:v>6</c:v>
+                </c:pt>
+                <c:pt idx="6">
+                  <c:v>7</c:v>
+                </c:pt>
+                <c:pt idx="7">
+                  <c:v>8</c:v>
+                </c:pt>
+                <c:pt idx="8">
+                  <c:v>9</c:v>
+                </c:pt>
+                <c:pt idx="9">
+                  <c:v>10</c:v>
+                </c:pt>
+                <c:pt idx="10">
+                  <c:v>11</c:v>
+                </c:pt>
+                <c:pt idx="11">
+                  <c:v>12</c:v>
+                </c:pt>
+                <c:pt idx="12">
+                  <c:v>13</c:v>
+                </c:pt>
+                <c:pt idx="13">
+                  <c:v>14</c:v>
+                </c:pt>
+                <c:pt idx="14">
+                  <c:v>15</c:v>
+                </c:pt>
+                <c:pt idx="15">
+                  <c:v>16</c:v>
+                </c:pt>
+                <c:pt idx="16">
+                  <c:v>17</c:v>
+                </c:pt>
+                <c:pt idx="17">
+                  <c:v>18</c:v>
+                </c:pt>
+                <c:pt idx="18">
+                  <c:v>19</c:v>
+                </c:pt>
+                <c:pt idx="19">
+                  <c:v>20</c:v>
+                </c:pt>
+                <c:pt idx="20">
+                  <c:v>21</c:v>
+                </c:pt>
+                <c:pt idx="21">
+                  <c:v>22</c:v>
+                </c:pt>
+                <c:pt idx="22">
+                  <c:v>23</c:v>
+                </c:pt>
+                <c:pt idx="23">
+                  <c:v>24</c:v>
+                </c:pt>
+                <c:pt idx="24">
+                  <c:v>25</c:v>
+                </c:pt>
+                <c:pt idx="25">
+                  <c:v>26</c:v>
+                </c:pt>
+                <c:pt idx="26">
+                  <c:v>27</c:v>
+                </c:pt>
+                <c:pt idx="27">
+                  <c:v>28</c:v>
+                </c:pt>
+                <c:pt idx="28">
+                  <c:v>29</c:v>
+                </c:pt>
+                <c:pt idx="29">
+                  <c:v>30</c:v>
+                </c:pt>
+                <c:pt idx="30">
+                  <c:v>31</c:v>
+                </c:pt>
+              </c:strCache>
+            </c:strRef>
+          </c:cat>
+          <c:val>
+            <c:numRef>
+              <c:f>Sheet1!$D$2:$D$32</c:f>
               <c:numCache>
                 <c:formatCode>General</c:formatCode>
                 <c:ptCount val="31"/>
-                <c:pt idx="0">
-                  <c:v>1250.0</c:v>
-                </c:pt>
-                <c:pt idx="1">
-                  <c:v>1390.24</c:v>
-                </c:pt>
-                <c:pt idx="2">
-                  <c:v>1465.96</c:v>
-                </c:pt>
-                <c:pt idx="3">
-                  <c:v>1881.42</c:v>
-                </c:pt>
-                <c:pt idx="4">
-                  <c:v>1838.65</c:v>
-                </c:pt>
-                <c:pt idx="5">
-                  <c:v>1981.97</c:v>
-                </c:pt>
-                <c:pt idx="6">
+                <c:pt idx="13">
                   <c:v>0.0</c:v>
                 </c:pt>
-                <c:pt idx="7">
-                  <c:v>1212.26</c:v>
-                </c:pt>
-                <c:pt idx="8">
-                  <c:v>1047.71</c:v>
-                </c:pt>
-                <c:pt idx="9">
-                  <c:v>1107.8</c:v>
-                </c:pt>
-                <c:pt idx="10">
-                  <c:v>1454.55</c:v>
-                </c:pt>
-                <c:pt idx="11">
-                  <c:v>1891.53</c:v>
-                </c:pt>
-                <c:pt idx="12">
-                  <c:v>2008.74</c:v>
-                </c:pt>
-                <c:pt idx="13">
-                  <c:v>1415.63</c:v>
-                </c:pt>
                 <c:pt idx="14">
-                  <c:v>1253.27</c:v>
-                </c:pt>
-                <c:pt idx="15">
-                  <c:v>1094.08</c:v>
-                </c:pt>
-                <c:pt idx="16">
-                  <c:v>1592.91</c:v>
-                </c:pt>
-                <c:pt idx="17">
-                  <c:v>1839.95</c:v>
-                </c:pt>
-                <c:pt idx="18">
-                  <c:v>1648.79</c:v>
-                </c:pt>
-                <c:pt idx="19">
-                  <c:v>1099.31</c:v>
-                </c:pt>
-                <c:pt idx="20">
-                  <c:v>1295.03</c:v>
-                </c:pt>
-                <c:pt idx="21">
                   <c:v>0.0</c:v>
-                </c:pt>
-                <c:pt idx="22">
-                  <c:v>1097.83</c:v>
-                </c:pt>
-                <c:pt idx="23">
-                  <c:v>1651.48</c:v>
-                </c:pt>
-                <c:pt idx="24">
-                  <c:v>2077.77</c:v>
-                </c:pt>
-                <c:pt idx="25">
-                  <c:v>1355.29</c:v>
-                </c:pt>
-                <c:pt idx="26">
-                  <c:v>1790.66</c:v>
-                </c:pt>
-                <c:pt idx="27">
-                  <c:v>1082.55</c:v>
-                </c:pt>
-                <c:pt idx="28">
-                  <c:v>1139.63</c:v>
-                </c:pt>
-                <c:pt idx="29">
-                  <c:v>1001.1</c:v>
                 </c:pt>
               </c:numCache>
             </c:numRef>
@@ -614,7 +779,28 @@
             </a:ln>
           </c:spPr>
         </c:majorGridlines>
-        <c:numFmt formatCode="#,##0" sourceLinked="0"/>
+        <c:title>
+          <c:tx>
+            <c:rich>
+              <a:bodyPr/>
+              <a:lstStyle/>
+              <a:p>
+                <a:r>
+                  <a:rPr sz="1200" b="0" i="0">
+                    <a:solidFill>
+                      <a:srgbClr val="5B6470"/>
+                    </a:solidFill>
+                    <a:latin typeface="Calibri"/>
+                  </a:rPr>
+                  <a:t>Net sales ($)</a:t>
+                </a:r>
+              </a:p>
+            </c:rich>
+          </c:tx>
+          <c:layout/>
+          <c:overlay val="0"/>
+        </c:title>
+        <c:numFmt formatCode="&quot;$&quot;#,##0" sourceLinked="0"/>
         <c:majorTickMark val="out"/>
         <c:minorTickMark val="none"/>
         <c:tickLblPos val="nextTo"/>
@@ -663,9 +849,9 @@
   <c:chart>
     <c:autoTitleDeleted val="1"/>
     <c:plotArea>
-      <c:barChart>
-        <c:barDir val="col"/>
-        <c:grouping val="clustered"/>
+      <c:lineChart>
+        <c:grouping val="standard"/>
+        <c:varyColors val="0"/>
         <c:ser>
           <c:idx val="0"/>
           <c:order val="0"/>
@@ -675,16 +861,38 @@
               <c:strCache>
                 <c:ptCount val="1"/>
                 <c:pt idx="0">
-                  <c:v>Orders</c:v>
+                  <c:v>October 2026</c:v>
                 </c:pt>
               </c:strCache>
             </c:strRef>
           </c:tx>
           <c:spPr>
-            <a:solidFill>
-              <a:srgbClr val="1B7F8C"/>
-            </a:solidFill>
+            <a:ln w="31750">
+              <a:solidFill>
+                <a:srgbClr val="1B7F8C"/>
+              </a:solidFill>
+            </a:ln>
           </c:spPr>
+          <c:marker>
+            <c:symbol val="none"/>
+          </c:marker>
+          <c:dPt>
+            <c:idx val="5"/>
+            <c:marker>
+              <c:symbol val="circle"/>
+              <c:size val="9"/>
+              <c:spPr>
+                <a:solidFill>
+                  <a:srgbClr val="1B7F8C"/>
+                </a:solidFill>
+                <a:ln>
+                  <a:solidFill>
+                    <a:srgbClr val="1B7F8C"/>
+                  </a:solidFill>
+                </a:ln>
+              </c:spPr>
+            </c:marker>
+          </c:dPt>
           <c:cat>
             <c:strRef>
               <c:f>Sheet1!$A$2:$A$32</c:f>
@@ -793,101 +1001,252 @@
                 <c:formatCode>General</c:formatCode>
                 <c:ptCount val="31"/>
                 <c:pt idx="0">
-                  <c:v>19</c:v>
+                  <c:v>19.0</c:v>
                 </c:pt>
                 <c:pt idx="1">
-                  <c:v>27</c:v>
+                  <c:v>27.0</c:v>
                 </c:pt>
                 <c:pt idx="2">
-                  <c:v>21</c:v>
+                  <c:v>21.0</c:v>
                 </c:pt>
                 <c:pt idx="3">
-                  <c:v>21</c:v>
+                  <c:v>21.0</c:v>
                 </c:pt>
                 <c:pt idx="4">
-                  <c:v>16</c:v>
+                  <c:v>16.0</c:v>
                 </c:pt>
                 <c:pt idx="5">
-                  <c:v>0</c:v>
+                  <c:v>0.0</c:v>
                 </c:pt>
                 <c:pt idx="6">
-                  <c:v>21</c:v>
+                  <c:v>21.0</c:v>
                 </c:pt>
                 <c:pt idx="7">
-                  <c:v>20</c:v>
+                  <c:v>20.0</c:v>
                 </c:pt>
                 <c:pt idx="8">
-                  <c:v>30</c:v>
+                  <c:v>30.0</c:v>
                 </c:pt>
                 <c:pt idx="9">
-                  <c:v>21</c:v>
+                  <c:v>21.0</c:v>
                 </c:pt>
                 <c:pt idx="10">
-                  <c:v>21</c:v>
+                  <c:v>21.0</c:v>
                 </c:pt>
                 <c:pt idx="11">
-                  <c:v>22</c:v>
+                  <c:v>22.0</c:v>
                 </c:pt>
                 <c:pt idx="12">
-                  <c:v>21</c:v>
+                  <c:v>21.0</c:v>
                 </c:pt>
                 <c:pt idx="15">
-                  <c:v>26</c:v>
+                  <c:v>26.0</c:v>
                 </c:pt>
                 <c:pt idx="16">
-                  <c:v>21</c:v>
+                  <c:v>21.0</c:v>
                 </c:pt>
                 <c:pt idx="17">
-                  <c:v>20</c:v>
+                  <c:v>20.0</c:v>
                 </c:pt>
                 <c:pt idx="18">
-                  <c:v>18</c:v>
+                  <c:v>18.0</c:v>
                 </c:pt>
                 <c:pt idx="19">
-                  <c:v>15</c:v>
+                  <c:v>15.0</c:v>
                 </c:pt>
                 <c:pt idx="20">
-                  <c:v>23</c:v>
+                  <c:v>23.0</c:v>
                 </c:pt>
                 <c:pt idx="21">
-                  <c:v>22</c:v>
+                  <c:v>22.0</c:v>
                 </c:pt>
                 <c:pt idx="22">
-                  <c:v>27</c:v>
+                  <c:v>27.0</c:v>
                 </c:pt>
                 <c:pt idx="23">
-                  <c:v>24</c:v>
+                  <c:v>24.0</c:v>
                 </c:pt>
                 <c:pt idx="24">
-                  <c:v>27</c:v>
+                  <c:v>27.0</c:v>
                 </c:pt>
                 <c:pt idx="25">
-                  <c:v>21</c:v>
+                  <c:v>21.0</c:v>
                 </c:pt>
                 <c:pt idx="26">
-                  <c:v>20</c:v>
+                  <c:v>20.0</c:v>
                 </c:pt>
                 <c:pt idx="27">
-                  <c:v>17</c:v>
+                  <c:v>17.0</c:v>
                 </c:pt>
                 <c:pt idx="28">
-                  <c:v>16</c:v>
+                  <c:v>16.0</c:v>
                 </c:pt>
                 <c:pt idx="29">
-                  <c:v>20</c:v>
+                  <c:v>20.0</c:v>
                 </c:pt>
                 <c:pt idx="30">
-                  <c:v>30</c:v>
+                  <c:v>30.0</c:v>
                 </c:pt>
               </c:numCache>
             </c:numRef>
           </c:val>
+          <c:smooth val="0"/>
         </c:ser>
-        <c:axId val="-2068027336"/>
-        <c:axId val="-2113994440"/>
-      </c:barChart>
+        <c:ser>
+          <c:idx val="1"/>
+          <c:order val="1"/>
+          <c:tx>
+            <c:strRef>
+              <c:f>Sheet1!$C$1</c:f>
+              <c:strCache>
+                <c:ptCount val="1"/>
+                <c:pt idx="0">
+                  <c:v>Day with no data</c:v>
+                </c:pt>
+              </c:strCache>
+            </c:strRef>
+          </c:tx>
+          <c:spPr>
+            <a:ln>
+              <a:noFill/>
+            </a:ln>
+          </c:spPr>
+          <c:marker>
+            <c:symbol val="x"/>
+            <c:size val="10"/>
+            <c:spPr>
+              <a:ln>
+                <a:solidFill>
+                  <a:srgbClr val="B44A1E"/>
+                </a:solidFill>
+              </a:ln>
+            </c:spPr>
+          </c:marker>
+          <c:cat>
+            <c:strRef>
+              <c:f>Sheet1!$A$2:$A$32</c:f>
+              <c:strCache>
+                <c:ptCount val="31"/>
+                <c:pt idx="0">
+                  <c:v>1</c:v>
+                </c:pt>
+                <c:pt idx="1">
+                  <c:v>2</c:v>
+                </c:pt>
+                <c:pt idx="2">
+                  <c:v>3</c:v>
+                </c:pt>
+                <c:pt idx="3">
+                  <c:v>4</c:v>
+                </c:pt>
+                <c:pt idx="4">
+                  <c:v>5</c:v>
+                </c:pt>
+                <c:pt idx="5">
+                  <c:v>6</c:v>
+                </c:pt>
+                <c:pt idx="6">
+                  <c:v>7</c:v>
+                </c:pt>
+                <c:pt idx="7">
+                  <c:v>8</c:v>
+                </c:pt>
+                <c:pt idx="8">
+                  <c:v>9</c:v>
+                </c:pt>
+                <c:pt idx="9">
+                  <c:v>10</c:v>
+                </c:pt>
+                <c:pt idx="10">
+                  <c:v>11</c:v>
+                </c:pt>
+                <c:pt idx="11">
+                  <c:v>12</c:v>
+                </c:pt>
+                <c:pt idx="12">
+                  <c:v>13</c:v>
+                </c:pt>
+                <c:pt idx="13">
+                  <c:v>14</c:v>
+                </c:pt>
+                <c:pt idx="14">
+                  <c:v>15</c:v>
+                </c:pt>
+                <c:pt idx="15">
+                  <c:v>16</c:v>
+                </c:pt>
+                <c:pt idx="16">
+                  <c:v>17</c:v>
+                </c:pt>
+                <c:pt idx="17">
+                  <c:v>18</c:v>
+                </c:pt>
+                <c:pt idx="18">
+                  <c:v>19</c:v>
+                </c:pt>
+                <c:pt idx="19">
+                  <c:v>20</c:v>
+                </c:pt>
+                <c:pt idx="20">
+                  <c:v>21</c:v>
+                </c:pt>
+                <c:pt idx="21">
+                  <c:v>22</c:v>
+                </c:pt>
+                <c:pt idx="22">
+                  <c:v>23</c:v>
+                </c:pt>
+                <c:pt idx="23">
+                  <c:v>24</c:v>
+                </c:pt>
+                <c:pt idx="24">
+                  <c:v>25</c:v>
+                </c:pt>
+                <c:pt idx="25">
+                  <c:v>26</c:v>
+                </c:pt>
+                <c:pt idx="26">
+                  <c:v>27</c:v>
+                </c:pt>
+                <c:pt idx="27">
+                  <c:v>28</c:v>
+                </c:pt>
+                <c:pt idx="28">
+                  <c:v>29</c:v>
+                </c:pt>
+                <c:pt idx="29">
+                  <c:v>30</c:v>
+                </c:pt>
+                <c:pt idx="30">
+                  <c:v>31</c:v>
+                </c:pt>
+              </c:strCache>
+            </c:strRef>
+          </c:cat>
+          <c:val>
+            <c:numRef>
+              <c:f>Sheet1!$C$2:$C$32</c:f>
+              <c:numCache>
+                <c:formatCode>General</c:formatCode>
+                <c:ptCount val="31"/>
+                <c:pt idx="13">
+                  <c:v>0.0</c:v>
+                </c:pt>
+                <c:pt idx="14">
+                  <c:v>0.0</c:v>
+                </c:pt>
+              </c:numCache>
+            </c:numRef>
+          </c:val>
+          <c:smooth val="0"/>
+        </c:ser>
+        <c:marker val="1"/>
+        <c:smooth val="0"/>
+        <c:axId val="2118791784"/>
+        <c:axId val="2140495176"/>
+      </c:lineChart>
       <c:catAx>
-        <c:axId val="-2068027336"/>
+        <c:axId val="2118791784"/>
         <c:scaling>
           <c:orientation val="minMax"/>
         </c:scaling>
@@ -903,7 +1262,7 @@
             </a:solidFill>
           </a:ln>
         </c:spPr>
-        <c:crossAx val="-2113994440"/>
+        <c:crossAx val="2140495176"/>
         <c:crosses val="autoZero"/>
         <c:auto val="1"/>
         <c:lblAlgn val="ctr"/>
@@ -911,7 +1270,7 @@
         <c:noMultiLvlLbl val="0"/>
       </c:catAx>
       <c:valAx>
-        <c:axId val="-2113994440"/>
+        <c:axId val="2140495176"/>
         <c:scaling/>
         <c:delete val="0"/>
         <c:axPos val="l"/>
@@ -924,6 +1283,27 @@
             </a:ln>
           </c:spPr>
         </c:majorGridlines>
+        <c:title>
+          <c:tx>
+            <c:rich>
+              <a:bodyPr/>
+              <a:lstStyle/>
+              <a:p>
+                <a:r>
+                  <a:rPr sz="1200" b="0" i="0">
+                    <a:solidFill>
+                      <a:srgbClr val="5B6470"/>
+                    </a:solidFill>
+                    <a:latin typeface="Calibri"/>
+                  </a:rPr>
+                  <a:t>Orders</a:t>
+                </a:r>
+              </a:p>
+            </c:rich>
+          </c:tx>
+          <c:layout/>
+          <c:overlay val="0"/>
+        </c:title>
         <c:numFmt formatCode="#,##0" sourceLinked="0"/>
         <c:majorTickMark val="out"/>
         <c:minorTickMark val="none"/>
@@ -933,11 +1313,18 @@
             <a:noFill/>
           </a:ln>
         </c:spPr>
-        <c:crossAx val="-2068027336"/>
+        <c:crossAx val="2118791784"/>
         <c:crosses val="autoZero"/>
       </c:valAx>
     </c:plotArea>
+    <c:legend>
+      <c:legendPos val="b"/>
+      <c:layout/>
+      <c:overlay val="0"/>
+    </c:legend>
+    <c:plotVisOnly val="1"/>
     <c:dispBlanksAs val="gap"/>
+    <c:showDLblsOverMax val="0"/>
   </c:chart>
   <c:txPr>
     <a:bodyPr/>
@@ -4002,7 +4389,7 @@
                 </a:solidFill>
                 <a:latin typeface="Calibri"/>
               </a:rPr>
-              <a:t>Demo store, October 2026</a:t>
+              <a:t>Example Outfitters, October 2026</a:t>
             </a:r>
           </a:p>
         </p:txBody>
@@ -4041,7 +4428,7 @@
                 </a:solidFill>
                 <a:latin typeface="Calibri"/>
               </a:rPr>
-              <a:t>Invented orders from a fixed seed. Not a real store.</a:t>
+              <a:t>Sample report: the orders are invented, not a real store.</a:t>
             </a:r>
           </a:p>
         </p:txBody>
@@ -4076,8 +4463,8 @@
         </p:nvSpPr>
         <p:spPr>
           <a:xfrm>
-            <a:off x="548640" y="320040"/>
-            <a:ext cx="11094415" cy="914400"/>
+            <a:off x="548640" y="274320"/>
+            <a:ext cx="11094415" cy="1005840"/>
           </a:xfrm>
         </p:spPr>
         <p:txBody>
@@ -4086,13 +4473,13 @@
           <a:p>
             <a:pPr algn="l"/>
             <a:r>
-              <a:rPr sz="2800" b="1" i="0">
+              <a:rPr sz="2400" b="1" i="0">
                 <a:solidFill>
                   <a:srgbClr val="1F3A5F"/>
                 </a:solidFill>
                 <a:latin typeface="Calibri"/>
               </a:rPr>
-              <a:t>Net sales fell 1.8% on September 2026 to USD 40,249.02</a:t>
+              <a:t>Net sales fell 1.8% from September (October is missing 2 days)</a:t>
             </a:r>
           </a:p>
         </p:txBody>
@@ -4116,12 +4503,12 @@
                 <a:tableStyleId>{5C22544A-7EE6-4342-B048-85BDC9FD1C3A}</a:tableStyleId>
               </a:tblPr>
               <a:tblGrid>
-                <a:gridCol w="2730932"/>
-                <a:gridCol w="1877516"/>
-                <a:gridCol w="1877516"/>
-                <a:gridCol w="1706833"/>
-                <a:gridCol w="1194783"/>
-                <a:gridCol w="1706833"/>
+                <a:gridCol w="2411829"/>
+                <a:gridCol w="1607886"/>
+                <a:gridCol w="1607886"/>
+                <a:gridCol w="1447097"/>
+                <a:gridCol w="1045126"/>
+                <a:gridCol w="2974589"/>
               </a:tblGrid>
               <a:tr h="530352">
                 <a:tc>
@@ -4131,7 +4518,7 @@
                     <a:p>
                       <a:pPr algn="l"/>
                       <a:r>
-                        <a:rPr sz="1500" b="1" i="0">
+                        <a:rPr sz="1400" b="1" i="0">
                           <a:solidFill>
                             <a:srgbClr val="FFFFFF"/>
                           </a:solidFill>
@@ -4154,7 +4541,7 @@
                     <a:p>
                       <a:pPr algn="r"/>
                       <a:r>
-                        <a:rPr sz="1500" b="1" i="0">
+                        <a:rPr sz="1400" b="1" i="0">
                           <a:solidFill>
                             <a:srgbClr val="FFFFFF"/>
                           </a:solidFill>
@@ -4177,7 +4564,7 @@
                     <a:p>
                       <a:pPr algn="r"/>
                       <a:r>
-                        <a:rPr sz="1500" b="1" i="0">
+                        <a:rPr sz="1400" b="1" i="0">
                           <a:solidFill>
                             <a:srgbClr val="FFFFFF"/>
                           </a:solidFill>
@@ -4200,7 +4587,7 @@
                     <a:p>
                       <a:pPr algn="r"/>
                       <a:r>
-                        <a:rPr sz="1500" b="1" i="0">
+                        <a:rPr sz="1400" b="1" i="0">
                           <a:solidFill>
                             <a:srgbClr val="FFFFFF"/>
                           </a:solidFill>
@@ -4223,7 +4610,7 @@
                     <a:p>
                       <a:pPr algn="r"/>
                       <a:r>
-                        <a:rPr sz="1500" b="1" i="0">
+                        <a:rPr sz="1400" b="1" i="0">
                           <a:solidFill>
                             <a:srgbClr val="FFFFFF"/>
                           </a:solidFill>
@@ -4246,7 +4633,7 @@
                     <a:p>
                       <a:pPr algn="r"/>
                       <a:r>
-                        <a:rPr sz="1500" b="1" i="0">
+                        <a:rPr sz="1400" b="1" i="0">
                           <a:solidFill>
                             <a:srgbClr val="FFFFFF"/>
                           </a:solidFill>
@@ -4271,7 +4658,7 @@
                     <a:p>
                       <a:pPr algn="l"/>
                       <a:r>
-                        <a:rPr sz="1500" b="0" i="0">
+                        <a:rPr sz="1400" b="0" i="0">
                           <a:solidFill>
                             <a:srgbClr val="2B2F36"/>
                           </a:solidFill>
@@ -4294,7 +4681,7 @@
                     <a:p>
                       <a:pPr algn="r"/>
                       <a:r>
-                        <a:rPr sz="1500" b="0" i="0">
+                        <a:rPr sz="1400" b="0" i="0">
                           <a:solidFill>
                             <a:srgbClr val="2B2F36"/>
                           </a:solidFill>
@@ -4317,7 +4704,7 @@
                     <a:p>
                       <a:pPr algn="r"/>
                       <a:r>
-                        <a:rPr sz="1500" b="0" i="0">
+                        <a:rPr sz="1400" b="0" i="0">
                           <a:solidFill>
                             <a:srgbClr val="2B2F36"/>
                           </a:solidFill>
@@ -4340,7 +4727,7 @@
                     <a:p>
                       <a:pPr algn="r"/>
                       <a:r>
-                        <a:rPr sz="1500" b="0" i="0">
+                        <a:rPr sz="1400" b="0" i="0">
                           <a:solidFill>
                             <a:srgbClr val="2B2F36"/>
                           </a:solidFill>
@@ -4363,7 +4750,7 @@
                     <a:p>
                       <a:pPr algn="r"/>
                       <a:r>
-                        <a:rPr sz="1500" b="0" i="0">
+                        <a:rPr sz="1400" b="0" i="0">
                           <a:solidFill>
                             <a:srgbClr val="2B2F36"/>
                           </a:solidFill>
@@ -4386,13 +4773,13 @@
                     <a:p>
                       <a:pPr algn="r"/>
                       <a:r>
-                        <a:rPr sz="1500" b="0" i="0">
+                        <a:rPr sz="1400" b="0" i="0">
                           <a:solidFill>
                             <a:srgbClr val="2B2F36"/>
                           </a:solidFill>
                           <a:latin typeface="Calibri"/>
                         </a:rPr>
-                        <a:t>partial data</a:t>
+                        <a:t>October partial: 2 days missing</a:t>
                       </a:r>
                     </a:p>
                   </a:txBody>
@@ -4411,7 +4798,7 @@
                     <a:p>
                       <a:pPr algn="l"/>
                       <a:r>
-                        <a:rPr sz="1500" b="0" i="0">
+                        <a:rPr sz="1400" b="0" i="0">
                           <a:solidFill>
                             <a:srgbClr val="2B2F36"/>
                           </a:solidFill>
@@ -4434,13 +4821,13 @@
                     <a:p>
                       <a:pPr algn="r"/>
                       <a:r>
-                        <a:rPr sz="1500" b="0" i="0">
+                        <a:rPr sz="1400" b="0" i="0">
                           <a:solidFill>
                             <a:srgbClr val="2B2F36"/>
                           </a:solidFill>
                           <a:latin typeface="Calibri"/>
                         </a:rPr>
-                        <a:t>USD 42,374.92</a:t>
+                        <a:t>$42,374.92</a:t>
                       </a:r>
                     </a:p>
                   </a:txBody>
@@ -4457,13 +4844,13 @@
                     <a:p>
                       <a:pPr algn="r"/>
                       <a:r>
-                        <a:rPr sz="1500" b="0" i="0">
+                        <a:rPr sz="1400" b="0" i="0">
                           <a:solidFill>
                             <a:srgbClr val="2B2F36"/>
                           </a:solidFill>
                           <a:latin typeface="Calibri"/>
                         </a:rPr>
-                        <a:t>USD 42,639.05</a:t>
+                        <a:t>$42,639.05</a:t>
                       </a:r>
                     </a:p>
                   </a:txBody>
@@ -4480,13 +4867,13 @@
                     <a:p>
                       <a:pPr algn="r"/>
                       <a:r>
-                        <a:rPr sz="1500" b="0" i="0">
+                        <a:rPr sz="1400" b="0" i="0">
                           <a:solidFill>
                             <a:srgbClr val="2B2F36"/>
                           </a:solidFill>
                           <a:latin typeface="Calibri"/>
                         </a:rPr>
-                        <a:t>-USD 264.13</a:t>
+                        <a:t>-$264.13</a:t>
                       </a:r>
                     </a:p>
                   </a:txBody>
@@ -4503,7 +4890,7 @@
                     <a:p>
                       <a:pPr algn="r"/>
                       <a:r>
-                        <a:rPr sz="1500" b="0" i="0">
+                        <a:rPr sz="1400" b="0" i="0">
                           <a:solidFill>
                             <a:srgbClr val="2B2F36"/>
                           </a:solidFill>
@@ -4526,13 +4913,13 @@
                     <a:p>
                       <a:pPr algn="r"/>
                       <a:r>
-                        <a:rPr sz="1500" b="0" i="0">
+                        <a:rPr sz="1400" b="0" i="0">
                           <a:solidFill>
                             <a:srgbClr val="2B2F36"/>
                           </a:solidFill>
                           <a:latin typeface="Calibri"/>
                         </a:rPr>
-                        <a:t>partial data</a:t>
+                        <a:t>October partial: 2 days missing</a:t>
                       </a:r>
                     </a:p>
                   </a:txBody>
@@ -4551,7 +4938,7 @@
                     <a:p>
                       <a:pPr algn="l"/>
                       <a:r>
-                        <a:rPr sz="1500" b="0" i="0">
+                        <a:rPr sz="1400" b="0" i="0">
                           <a:solidFill>
                             <a:srgbClr val="2B2F36"/>
                           </a:solidFill>
@@ -4574,13 +4961,13 @@
                     <a:p>
                       <a:pPr algn="r"/>
                       <a:r>
-                        <a:rPr sz="1500" b="0" i="0">
+                        <a:rPr sz="1400" b="0" i="0">
                           <a:solidFill>
                             <a:srgbClr val="2B2F36"/>
                           </a:solidFill>
                           <a:latin typeface="Calibri"/>
                         </a:rPr>
-                        <a:t>USD 2,125.90</a:t>
+                        <a:t>$2,125.90</a:t>
                       </a:r>
                     </a:p>
                   </a:txBody>
@@ -4597,13 +4984,13 @@
                     <a:p>
                       <a:pPr algn="r"/>
                       <a:r>
-                        <a:rPr sz="1500" b="0" i="0">
+                        <a:rPr sz="1400" b="0" i="0">
                           <a:solidFill>
                             <a:srgbClr val="2B2F36"/>
                           </a:solidFill>
                           <a:latin typeface="Calibri"/>
                         </a:rPr>
-                        <a:t>USD 1,672.94</a:t>
+                        <a:t>$1,672.94</a:t>
                       </a:r>
                     </a:p>
                   </a:txBody>
@@ -4620,13 +5007,13 @@
                     <a:p>
                       <a:pPr algn="r"/>
                       <a:r>
-                        <a:rPr sz="1500" b="0" i="0">
+                        <a:rPr sz="1400" b="0" i="0">
                           <a:solidFill>
                             <a:srgbClr val="2B2F36"/>
                           </a:solidFill>
                           <a:latin typeface="Calibri"/>
                         </a:rPr>
-                        <a:t>+USD 452.96</a:t>
+                        <a:t>+$452.96</a:t>
                       </a:r>
                     </a:p>
                   </a:txBody>
@@ -4643,7 +5030,7 @@
                     <a:p>
                       <a:pPr algn="r"/>
                       <a:r>
-                        <a:rPr sz="1500" b="0" i="0">
+                        <a:rPr sz="1400" b="0" i="0">
                           <a:solidFill>
                             <a:srgbClr val="2B2F36"/>
                           </a:solidFill>
@@ -4666,13 +5053,13 @@
                     <a:p>
                       <a:pPr algn="r"/>
                       <a:r>
-                        <a:rPr sz="1500" b="0" i="0">
+                        <a:rPr sz="1400" b="0" i="0">
                           <a:solidFill>
                             <a:srgbClr val="2B2F36"/>
                           </a:solidFill>
                           <a:latin typeface="Calibri"/>
                         </a:rPr>
-                        <a:t>partial data</a:t>
+                        <a:t>October partial: 2 days missing</a:t>
                       </a:r>
                     </a:p>
                   </a:txBody>
@@ -4691,7 +5078,7 @@
                     <a:p>
                       <a:pPr algn="l"/>
                       <a:r>
-                        <a:rPr sz="1500" b="0" i="0">
+                        <a:rPr sz="1400" b="0" i="0">
                           <a:solidFill>
                             <a:srgbClr val="2B2F36"/>
                           </a:solidFill>
@@ -4714,13 +5101,13 @@
                     <a:p>
                       <a:pPr algn="r"/>
                       <a:r>
-                        <a:rPr sz="1500" b="0" i="0">
+                        <a:rPr sz="1400" b="0" i="0">
                           <a:solidFill>
                             <a:srgbClr val="2B2F36"/>
                           </a:solidFill>
                           <a:latin typeface="Calibri"/>
                         </a:rPr>
-                        <a:t>USD 40,249.02</a:t>
+                        <a:t>$40,249.02</a:t>
                       </a:r>
                     </a:p>
                   </a:txBody>
@@ -4737,13 +5124,13 @@
                     <a:p>
                       <a:pPr algn="r"/>
                       <a:r>
-                        <a:rPr sz="1500" b="0" i="0">
+                        <a:rPr sz="1400" b="0" i="0">
                           <a:solidFill>
                             <a:srgbClr val="2B2F36"/>
                           </a:solidFill>
                           <a:latin typeface="Calibri"/>
                         </a:rPr>
-                        <a:t>USD 40,966.11</a:t>
+                        <a:t>$40,966.11</a:t>
                       </a:r>
                     </a:p>
                   </a:txBody>
@@ -4760,13 +5147,13 @@
                     <a:p>
                       <a:pPr algn="r"/>
                       <a:r>
-                        <a:rPr sz="1500" b="0" i="0">
+                        <a:rPr sz="1400" b="0" i="0">
                           <a:solidFill>
                             <a:srgbClr val="2B2F36"/>
                           </a:solidFill>
                           <a:latin typeface="Calibri"/>
                         </a:rPr>
-                        <a:t>-USD 717.09</a:t>
+                        <a:t>-$717.09</a:t>
                       </a:r>
                     </a:p>
                   </a:txBody>
@@ -4783,7 +5170,7 @@
                     <a:p>
                       <a:pPr algn="r"/>
                       <a:r>
-                        <a:rPr sz="1500" b="0" i="0">
+                        <a:rPr sz="1400" b="0" i="0">
                           <a:solidFill>
                             <a:srgbClr val="2B2F36"/>
                           </a:solidFill>
@@ -4806,13 +5193,13 @@
                     <a:p>
                       <a:pPr algn="r"/>
                       <a:r>
-                        <a:rPr sz="1500" b="0" i="0">
+                        <a:rPr sz="1400" b="0" i="0">
                           <a:solidFill>
                             <a:srgbClr val="2B2F36"/>
                           </a:solidFill>
                           <a:latin typeface="Calibri"/>
                         </a:rPr>
-                        <a:t>partial data</a:t>
+                        <a:t>October partial: 2 days missing</a:t>
                       </a:r>
                     </a:p>
                   </a:txBody>
@@ -4831,7 +5218,7 @@
                     <a:p>
                       <a:pPr algn="l"/>
                       <a:r>
-                        <a:rPr sz="1500" b="0" i="0">
+                        <a:rPr sz="1400" b="0" i="0">
                           <a:solidFill>
                             <a:srgbClr val="2B2F36"/>
                           </a:solidFill>
@@ -4854,13 +5241,13 @@
                     <a:p>
                       <a:pPr algn="r"/>
                       <a:r>
-                        <a:rPr sz="1500" b="0" i="0">
+                        <a:rPr sz="1400" b="0" i="0">
                           <a:solidFill>
                             <a:srgbClr val="2B2F36"/>
                           </a:solidFill>
                           <a:latin typeface="Calibri"/>
                         </a:rPr>
-                        <a:t>USD 69.81</a:t>
+                        <a:t>$69.81</a:t>
                       </a:r>
                     </a:p>
                   </a:txBody>
@@ -4877,13 +5264,13 @@
                     <a:p>
                       <a:pPr algn="r"/>
                       <a:r>
-                        <a:rPr sz="1500" b="0" i="0">
+                        <a:rPr sz="1400" b="0" i="0">
                           <a:solidFill>
                             <a:srgbClr val="2B2F36"/>
                           </a:solidFill>
                           <a:latin typeface="Calibri"/>
                         </a:rPr>
-                        <a:t>USD 72.39</a:t>
+                        <a:t>$72.39</a:t>
                       </a:r>
                     </a:p>
                   </a:txBody>
@@ -4900,13 +5287,13 @@
                     <a:p>
                       <a:pPr algn="r"/>
                       <a:r>
-                        <a:rPr sz="1500" b="0" i="0">
+                        <a:rPr sz="1400" b="0" i="0">
                           <a:solidFill>
                             <a:srgbClr val="2B2F36"/>
                           </a:solidFill>
                           <a:latin typeface="Calibri"/>
                         </a:rPr>
-                        <a:t>-USD 2.58</a:t>
+                        <a:t>-$2.58</a:t>
                       </a:r>
                     </a:p>
                   </a:txBody>
@@ -4923,7 +5310,7 @@
                     <a:p>
                       <a:pPr algn="r"/>
                       <a:r>
-                        <a:rPr sz="1500" b="0" i="0">
+                        <a:rPr sz="1400" b="0" i="0">
                           <a:solidFill>
                             <a:srgbClr val="2B2F36"/>
                           </a:solidFill>
@@ -4946,13 +5333,13 @@
                     <a:p>
                       <a:pPr algn="r"/>
                       <a:r>
-                        <a:rPr sz="1500" b="0" i="0">
+                        <a:rPr sz="1400" b="0" i="0">
                           <a:solidFill>
                             <a:srgbClr val="2B2F36"/>
                           </a:solidFill>
                           <a:latin typeface="Calibri"/>
                         </a:rPr>
-                        <a:t>partial data</a:t>
+                        <a:t>October partial: 2 days missing</a:t>
                       </a:r>
                     </a:p>
                   </a:txBody>
@@ -4971,7 +5358,7 @@
                     <a:p>
                       <a:pPr algn="l"/>
                       <a:r>
-                        <a:rPr sz="1500" b="0" i="0">
+                        <a:rPr sz="1400" b="0" i="0">
                           <a:solidFill>
                             <a:srgbClr val="2B2F36"/>
                           </a:solidFill>
@@ -4994,7 +5381,7 @@
                     <a:p>
                       <a:pPr algn="r"/>
                       <a:r>
-                        <a:rPr sz="1500" b="0" i="0">
+                        <a:rPr sz="1400" b="0" i="0">
                           <a:solidFill>
                             <a:srgbClr val="2B2F36"/>
                           </a:solidFill>
@@ -5017,7 +5404,7 @@
                     <a:p>
                       <a:pPr algn="r"/>
                       <a:r>
-                        <a:rPr sz="1500" b="0" i="0">
+                        <a:rPr sz="1400" b="0" i="0">
                           <a:solidFill>
                             <a:srgbClr val="2B2F36"/>
                           </a:solidFill>
@@ -5040,7 +5427,7 @@
                     <a:p>
                       <a:pPr algn="r"/>
                       <a:r>
-                        <a:rPr sz="1500" b="0" i="0">
+                        <a:rPr sz="1400" b="0" i="0">
                           <a:solidFill>
                             <a:srgbClr val="2B2F36"/>
                           </a:solidFill>
@@ -5063,13 +5450,13 @@
                     <a:p>
                       <a:pPr algn="r"/>
                       <a:r>
-                        <a:rPr sz="1500" b="0" i="0">
+                        <a:rPr sz="1400" b="0" i="0">
                           <a:solidFill>
                             <a:srgbClr val="2B2F36"/>
                           </a:solidFill>
                           <a:latin typeface="Calibri"/>
                         </a:rPr>
-                        <a:t>+7.2%</a:t>
+                        <a:t>+7.1%</a:t>
                       </a:r>
                     </a:p>
                   </a:txBody>
@@ -5086,13 +5473,13 @@
                     <a:p>
                       <a:pPr algn="r"/>
                       <a:r>
-                        <a:rPr sz="1500" b="0" i="0">
+                        <a:rPr sz="1400" b="0" i="0">
                           <a:solidFill>
                             <a:srgbClr val="2B2F36"/>
                           </a:solidFill>
                           <a:latin typeface="Calibri"/>
                         </a:rPr>
-                        <a:t>partial data</a:t>
+                        <a:t>October partial: 2 days missing</a:t>
                       </a:r>
                     </a:p>
                   </a:txBody>
@@ -5115,8 +5502,8 @@
         </p:nvSpPr>
         <p:spPr>
           <a:xfrm>
-            <a:off x="548640" y="6355080"/>
-            <a:ext cx="11094415" cy="320040"/>
+            <a:off x="548640" y="5989320"/>
+            <a:ext cx="11094415" cy="731520"/>
           </a:xfrm>
           <a:prstGeom prst="rect">
             <a:avLst/>
@@ -5141,7 +5528,23 @@
                 </a:solidFill>
                 <a:latin typeface="Calibri"/>
               </a:rPr>
-              <a:t>Source: stored daily snapshots. Change % is the change over the previous month's value, n/a when that value is zero or absent.</a:t>
+              <a:t>Source: the store's daily order records.</a:t>
+            </a:r>
+          </a:p>
+          <a:p>
+            <a:pPr>
+              <a:spcAft>
+                <a:spcPts val="0"/>
+              </a:spcAft>
+            </a:pPr>
+            <a:r>
+              <a:rPr sz="1100" b="0" i="0">
+                <a:solidFill>
+                  <a:srgbClr val="5B6470"/>
+                </a:solidFill>
+                <a:latin typeface="Calibri"/>
+              </a:rPr>
+              <a:t>Change % is the change over September's figure, n/a when that was zero. Buyers per active day is the average of each day's distinct buyers, over days with orders. Average order value is gross sales divided by orders.</a:t>
             </a:r>
           </a:p>
         </p:txBody>
@@ -5176,8 +5579,8 @@
         </p:nvSpPr>
         <p:spPr>
           <a:xfrm>
-            <a:off x="548640" y="320040"/>
-            <a:ext cx="11094415" cy="914400"/>
+            <a:off x="548640" y="274320"/>
+            <a:ext cx="11094415" cy="1005840"/>
           </a:xfrm>
         </p:spPr>
         <p:txBody>
@@ -5192,7 +5595,7 @@
                 </a:solidFill>
                 <a:latin typeface="Calibri"/>
               </a:rPr>
-              <a:t>Net sales by day, October 2026</a:t>
+              <a:t>Net sales by day in October</a:t>
             </a:r>
           </a:p>
         </p:txBody>
@@ -5223,8 +5626,8 @@
         </p:nvSpPr>
         <p:spPr>
           <a:xfrm>
-            <a:off x="548640" y="6355080"/>
-            <a:ext cx="11094415" cy="320040"/>
+            <a:off x="548640" y="5989320"/>
+            <a:ext cx="11094415" cy="731520"/>
           </a:xfrm>
           <a:prstGeom prst="rect">
             <a:avLst/>
@@ -5249,7 +5652,39 @@
                 </a:solidFill>
                 <a:latin typeface="Calibri"/>
               </a:rPr>
-              <a:t>Day of the month on the horizontal axis, net sales in USD. Gaps in the line are days with no snapshot and no sync run: 2026-10-14, 2026-10-15.</a:t>
+              <a:t>Day of the month across, net sales in dollars up.</a:t>
+            </a:r>
+          </a:p>
+          <a:p>
+            <a:pPr>
+              <a:spcAft>
+                <a:spcPts val="0"/>
+              </a:spcAft>
+            </a:pPr>
+            <a:r>
+              <a:rPr sz="1100" b="0" i="0">
+                <a:solidFill>
+                  <a:srgbClr val="5B6470"/>
+                </a:solidFill>
+                <a:latin typeface="Calibri"/>
+              </a:rPr>
+              <a:t>A dot on the zero line is a day with no orders.</a:t>
+            </a:r>
+          </a:p>
+          <a:p>
+            <a:pPr>
+              <a:spcAft>
+                <a:spcPts val="0"/>
+              </a:spcAft>
+            </a:pPr>
+            <a:r>
+              <a:rPr sz="1100" b="0" i="0">
+                <a:solidFill>
+                  <a:srgbClr val="5B6470"/>
+                </a:solidFill>
+                <a:latin typeface="Calibri"/>
+              </a:rPr>
+              <a:t>A break in the line with an X on the zero line is a day with no data (Oct 14, Oct 15). 29 of 31 days are plotted.</a:t>
             </a:r>
           </a:p>
         </p:txBody>
@@ -5284,8 +5719,8 @@
         </p:nvSpPr>
         <p:spPr>
           <a:xfrm>
-            <a:off x="548640" y="320040"/>
-            <a:ext cx="11094415" cy="914400"/>
+            <a:off x="548640" y="274320"/>
+            <a:ext cx="11094415" cy="1005840"/>
           </a:xfrm>
         </p:spPr>
         <p:txBody>
@@ -5300,14 +5735,14 @@
                 </a:solidFill>
                 <a:latin typeface="Calibri"/>
               </a:rPr>
-              <a:t>Orders by day, October 2026</a:t>
+              <a:t>Orders by day in October</a:t>
             </a:r>
           </a:p>
         </p:txBody>
       </p:sp>
       <p:graphicFrame>
         <p:nvGraphicFramePr>
-          <p:cNvPr id="3" name="Chart 2" descr="Column chart of orders for each day of October 2026"/>
+          <p:cNvPr id="3" name="Chart 2" descr="Line chart of orders for each day of October 2026"/>
           <p:cNvGraphicFramePr>
             <a:graphicFrameLocks noGrp="1"/>
           </p:cNvGraphicFramePr>
@@ -5331,8 +5766,8 @@
         </p:nvSpPr>
         <p:spPr>
           <a:xfrm>
-            <a:off x="548640" y="6355080"/>
-            <a:ext cx="11094415" cy="320040"/>
+            <a:off x="548640" y="5989320"/>
+            <a:ext cx="11094415" cy="731520"/>
           </a:xfrm>
           <a:prstGeom prst="rect">
             <a:avLst/>
@@ -5357,7 +5792,39 @@
                 </a:solidFill>
                 <a:latin typeface="Calibri"/>
               </a:rPr>
-              <a:t>Day of the month on the horizontal axis. A day with no column had no orders or no data. Days with no snapshot and no sync run: 2026-10-14, 2026-10-15.</a:t>
+              <a:t>Day of the month across, orders up.</a:t>
+            </a:r>
+          </a:p>
+          <a:p>
+            <a:pPr>
+              <a:spcAft>
+                <a:spcPts val="0"/>
+              </a:spcAft>
+            </a:pPr>
+            <a:r>
+              <a:rPr sz="1100" b="0" i="0">
+                <a:solidFill>
+                  <a:srgbClr val="5B6470"/>
+                </a:solidFill>
+                <a:latin typeface="Calibri"/>
+              </a:rPr>
+              <a:t>A dot on the zero line is a day with no orders.</a:t>
+            </a:r>
+          </a:p>
+          <a:p>
+            <a:pPr>
+              <a:spcAft>
+                <a:spcPts val="0"/>
+              </a:spcAft>
+            </a:pPr>
+            <a:r>
+              <a:rPr sz="1100" b="0" i="0">
+                <a:solidFill>
+                  <a:srgbClr val="5B6470"/>
+                </a:solidFill>
+                <a:latin typeface="Calibri"/>
+              </a:rPr>
+              <a:t>A break in the line with an X on the zero line is a day with no data (Oct 14, Oct 15). 29 of 31 days are plotted.</a:t>
             </a:r>
           </a:p>
         </p:txBody>
@@ -5392,8 +5859,8 @@
         </p:nvSpPr>
         <p:spPr>
           <a:xfrm>
-            <a:off x="548640" y="320040"/>
-            <a:ext cx="11094415" cy="914400"/>
+            <a:off x="548640" y="274320"/>
+            <a:ext cx="11094415" cy="1005840"/>
           </a:xfrm>
         </p:spPr>
         <p:txBody>
@@ -5408,7 +5875,7 @@
                 </a:solidFill>
                 <a:latin typeface="Calibri"/>
               </a:rPr>
-              <a:t>Average order value fell 3.6% on September 2026 to USD 69.81</a:t>
+              <a:t>Order value, buyers and best days in October</a:t>
             </a:r>
           </a:p>
         </p:txBody>
@@ -5422,8 +5889,8 @@
           <p:nvPr/>
         </p:nvGraphicFramePr>
         <p:xfrm>
-          <a:off x="548640" y="1463040"/>
-          <a:ext cx="11094414" cy="1508760"/>
+          <a:off x="548640" y="1371600"/>
+          <a:ext cx="11094413" cy="1508760"/>
         </p:xfrm>
         <a:graphic>
           <a:graphicData uri="http://schemas.openxmlformats.org/drawingml/2006/table">
@@ -5432,11 +5899,12 @@
                 <a:tableStyleId>{5C22544A-7EE6-4342-B048-85BDC9FD1C3A}</a:tableStyleId>
               </a:tblPr>
               <a:tblGrid>
-                <a:gridCol w="3251811"/>
-                <a:gridCol w="2295396"/>
-                <a:gridCol w="2295396"/>
-                <a:gridCol w="1912830"/>
-                <a:gridCol w="1338981"/>
+                <a:gridCol w="2411829"/>
+                <a:gridCol w="1607886"/>
+                <a:gridCol w="1607886"/>
+                <a:gridCol w="1447097"/>
+                <a:gridCol w="1045126"/>
+                <a:gridCol w="2974589"/>
               </a:tblGrid>
               <a:tr h="502920">
                 <a:tc>
@@ -5446,7 +5914,7 @@
                     <a:p>
                       <a:pPr algn="l"/>
                       <a:r>
-                        <a:rPr sz="1600" b="1" i="0">
+                        <a:rPr sz="1400" b="1" i="0">
                           <a:solidFill>
                             <a:srgbClr val="FFFFFF"/>
                           </a:solidFill>
@@ -5469,7 +5937,7 @@
                     <a:p>
                       <a:pPr algn="r"/>
                       <a:r>
-                        <a:rPr sz="1600" b="1" i="0">
+                        <a:rPr sz="1400" b="1" i="0">
                           <a:solidFill>
                             <a:srgbClr val="FFFFFF"/>
                           </a:solidFill>
@@ -5492,7 +5960,7 @@
                     <a:p>
                       <a:pPr algn="r"/>
                       <a:r>
-                        <a:rPr sz="1600" b="1" i="0">
+                        <a:rPr sz="1400" b="1" i="0">
                           <a:solidFill>
                             <a:srgbClr val="FFFFFF"/>
                           </a:solidFill>
@@ -5515,7 +5983,7 @@
                     <a:p>
                       <a:pPr algn="r"/>
                       <a:r>
-                        <a:rPr sz="1600" b="1" i="0">
+                        <a:rPr sz="1400" b="1" i="0">
                           <a:solidFill>
                             <a:srgbClr val="FFFFFF"/>
                           </a:solidFill>
@@ -5538,13 +6006,36 @@
                     <a:p>
                       <a:pPr algn="r"/>
                       <a:r>
-                        <a:rPr sz="1600" b="1" i="0">
+                        <a:rPr sz="1400" b="1" i="0">
                           <a:solidFill>
                             <a:srgbClr val="FFFFFF"/>
                           </a:solidFill>
                           <a:latin typeface="Calibri"/>
                         </a:rPr>
                         <a:t>Change %</a:t>
+                      </a:r>
+                    </a:p>
+                  </a:txBody>
+                  <a:tcPr anchor="ctr">
+                    <a:solidFill>
+                      <a:srgbClr val="1F3A5F"/>
+                    </a:solidFill>
+                  </a:tcPr>
+                </a:tc>
+                <a:tc>
+                  <a:txBody>
+                    <a:bodyPr/>
+                    <a:lstStyle/>
+                    <a:p>
+                      <a:pPr algn="r"/>
+                      <a:r>
+                        <a:rPr sz="1400" b="1" i="0">
+                          <a:solidFill>
+                            <a:srgbClr val="FFFFFF"/>
+                          </a:solidFill>
+                          <a:latin typeface="Calibri"/>
+                        </a:rPr>
+                        <a:t>Note</a:t>
                       </a:r>
                     </a:p>
                   </a:txBody>
@@ -5563,7 +6054,7 @@
                     <a:p>
                       <a:pPr algn="l"/>
                       <a:r>
-                        <a:rPr sz="1600" b="0" i="0">
+                        <a:rPr sz="1400" b="0" i="0">
                           <a:solidFill>
                             <a:srgbClr val="2B2F36"/>
                           </a:solidFill>
@@ -5586,13 +6077,13 @@
                     <a:p>
                       <a:pPr algn="r"/>
                       <a:r>
-                        <a:rPr sz="1600" b="0" i="0">
+                        <a:rPr sz="1400" b="0" i="0">
                           <a:solidFill>
                             <a:srgbClr val="2B2F36"/>
                           </a:solidFill>
                           <a:latin typeface="Calibri"/>
                         </a:rPr>
-                        <a:t>USD 69.81</a:t>
+                        <a:t>$69.81</a:t>
                       </a:r>
                     </a:p>
                   </a:txBody>
@@ -5609,13 +6100,13 @@
                     <a:p>
                       <a:pPr algn="r"/>
                       <a:r>
-                        <a:rPr sz="1600" b="0" i="0">
+                        <a:rPr sz="1400" b="0" i="0">
                           <a:solidFill>
                             <a:srgbClr val="2B2F36"/>
                           </a:solidFill>
                           <a:latin typeface="Calibri"/>
                         </a:rPr>
-                        <a:t>USD 72.39</a:t>
+                        <a:t>$72.39</a:t>
                       </a:r>
                     </a:p>
                   </a:txBody>
@@ -5632,13 +6123,13 @@
                     <a:p>
                       <a:pPr algn="r"/>
                       <a:r>
-                        <a:rPr sz="1600" b="0" i="0">
+                        <a:rPr sz="1400" b="0" i="0">
                           <a:solidFill>
                             <a:srgbClr val="2B2F36"/>
                           </a:solidFill>
                           <a:latin typeface="Calibri"/>
                         </a:rPr>
-                        <a:t>-USD 2.58</a:t>
+                        <a:t>-$2.58</a:t>
                       </a:r>
                     </a:p>
                   </a:txBody>
@@ -5655,13 +6146,36 @@
                     <a:p>
                       <a:pPr algn="r"/>
                       <a:r>
-                        <a:rPr sz="1600" b="0" i="0">
+                        <a:rPr sz="1400" b="0" i="0">
                           <a:solidFill>
                             <a:srgbClr val="2B2F36"/>
                           </a:solidFill>
                           <a:latin typeface="Calibri"/>
                         </a:rPr>
                         <a:t>-3.6%</a:t>
+                      </a:r>
+                    </a:p>
+                  </a:txBody>
+                  <a:tcPr anchor="ctr">
+                    <a:solidFill>
+                      <a:srgbClr val="FFFFFF"/>
+                    </a:solidFill>
+                  </a:tcPr>
+                </a:tc>
+                <a:tc>
+                  <a:txBody>
+                    <a:bodyPr/>
+                    <a:lstStyle/>
+                    <a:p>
+                      <a:pPr algn="r"/>
+                      <a:r>
+                        <a:rPr sz="1400" b="0" i="0">
+                          <a:solidFill>
+                            <a:srgbClr val="2B2F36"/>
+                          </a:solidFill>
+                          <a:latin typeface="Calibri"/>
+                        </a:rPr>
+                        <a:t>October partial: 2 days missing</a:t>
                       </a:r>
                     </a:p>
                   </a:txBody>
@@ -5680,7 +6194,7 @@
                     <a:p>
                       <a:pPr algn="l"/>
                       <a:r>
-                        <a:rPr sz="1600" b="0" i="0">
+                        <a:rPr sz="1400" b="0" i="0">
                           <a:solidFill>
                             <a:srgbClr val="2B2F36"/>
                           </a:solidFill>
@@ -5703,7 +6217,7 @@
                     <a:p>
                       <a:pPr algn="r"/>
                       <a:r>
-                        <a:rPr sz="1600" b="0" i="0">
+                        <a:rPr sz="1400" b="0" i="0">
                           <a:solidFill>
                             <a:srgbClr val="2B2F36"/>
                           </a:solidFill>
@@ -5726,7 +6240,7 @@
                     <a:p>
                       <a:pPr algn="r"/>
                       <a:r>
-                        <a:rPr sz="1600" b="0" i="0">
+                        <a:rPr sz="1400" b="0" i="0">
                           <a:solidFill>
                             <a:srgbClr val="2B2F36"/>
                           </a:solidFill>
@@ -5749,7 +6263,7 @@
                     <a:p>
                       <a:pPr algn="r"/>
                       <a:r>
-                        <a:rPr sz="1600" b="0" i="0">
+                        <a:rPr sz="1400" b="0" i="0">
                           <a:solidFill>
                             <a:srgbClr val="2B2F36"/>
                           </a:solidFill>
@@ -5772,13 +6286,36 @@
                     <a:p>
                       <a:pPr algn="r"/>
                       <a:r>
-                        <a:rPr sz="1600" b="0" i="0">
+                        <a:rPr sz="1400" b="0" i="0">
                           <a:solidFill>
                             <a:srgbClr val="2B2F36"/>
                           </a:solidFill>
                           <a:latin typeface="Calibri"/>
                         </a:rPr>
-                        <a:t>+7.2%</a:t>
+                        <a:t>+7.1%</a:t>
+                      </a:r>
+                    </a:p>
+                  </a:txBody>
+                  <a:tcPr anchor="ctr">
+                    <a:solidFill>
+                      <a:srgbClr val="F1F4F7"/>
+                    </a:solidFill>
+                  </a:tcPr>
+                </a:tc>
+                <a:tc>
+                  <a:txBody>
+                    <a:bodyPr/>
+                    <a:lstStyle/>
+                    <a:p>
+                      <a:pPr algn="r"/>
+                      <a:r>
+                        <a:rPr sz="1400" b="0" i="0">
+                          <a:solidFill>
+                            <a:srgbClr val="2B2F36"/>
+                          </a:solidFill>
+                          <a:latin typeface="Calibri"/>
+                        </a:rPr>
+                        <a:t>October partial: 2 days missing</a:t>
                       </a:r>
                     </a:p>
                   </a:txBody>
@@ -5801,7 +6338,7 @@
         </p:nvSpPr>
         <p:spPr>
           <a:xfrm>
-            <a:off x="548640" y="3246120"/>
+            <a:off x="548640" y="3063240"/>
             <a:ext cx="11094415" cy="365760"/>
           </a:xfrm>
           <a:prstGeom prst="rect">
@@ -5841,8 +6378,8 @@
           <p:nvPr/>
         </p:nvGraphicFramePr>
         <p:xfrm>
-          <a:off x="548640" y="3657600"/>
-          <a:ext cx="11094414" cy="1828800"/>
+          <a:off x="548640" y="3474720"/>
+          <a:ext cx="5486399" cy="1828800"/>
         </p:xfrm>
         <a:graphic>
           <a:graphicData uri="http://schemas.openxmlformats.org/drawingml/2006/table">
@@ -5851,9 +6388,9 @@
                 <a:tableStyleId>{5C22544A-7EE6-4342-B048-85BDC9FD1C3A}</a:tableStyleId>
               </a:tblPr>
               <a:tblGrid>
-                <a:gridCol w="1584916"/>
-                <a:gridCol w="4754749"/>
-                <a:gridCol w="4754749"/>
+                <a:gridCol w="914400"/>
+                <a:gridCol w="2011680"/>
+                <a:gridCol w="2560319"/>
               </a:tblGrid>
               <a:tr h="457200">
                 <a:tc>
@@ -5863,7 +6400,7 @@
                     <a:p>
                       <a:pPr algn="l"/>
                       <a:r>
-                        <a:rPr sz="1600" b="1" i="0">
+                        <a:rPr sz="1500" b="1" i="0">
                           <a:solidFill>
                             <a:srgbClr val="FFFFFF"/>
                           </a:solidFill>
@@ -5886,7 +6423,7 @@
                     <a:p>
                       <a:pPr algn="l"/>
                       <a:r>
-                        <a:rPr sz="1600" b="1" i="0">
+                        <a:rPr sz="1500" b="1" i="0">
                           <a:solidFill>
                             <a:srgbClr val="FFFFFF"/>
                           </a:solidFill>
@@ -5909,7 +6446,7 @@
                     <a:p>
                       <a:pPr algn="r"/>
                       <a:r>
-                        <a:rPr sz="1600" b="1" i="0">
+                        <a:rPr sz="1500" b="1" i="0">
                           <a:solidFill>
                             <a:srgbClr val="FFFFFF"/>
                           </a:solidFill>
@@ -5934,7 +6471,7 @@
                     <a:p>
                       <a:pPr algn="l"/>
                       <a:r>
-                        <a:rPr sz="1600" b="0" i="0">
+                        <a:rPr sz="1500" b="0" i="0">
                           <a:solidFill>
                             <a:srgbClr val="2B2F36"/>
                           </a:solidFill>
@@ -5957,13 +6494,13 @@
                     <a:p>
                       <a:pPr algn="l"/>
                       <a:r>
-                        <a:rPr sz="1600" b="0" i="0">
+                        <a:rPr sz="1500" b="0" i="0">
                           <a:solidFill>
                             <a:srgbClr val="2B2F36"/>
                           </a:solidFill>
                           <a:latin typeface="Calibri"/>
                         </a:rPr>
-                        <a:t>2026-10-31</a:t>
+                        <a:t>Oct 31</a:t>
                       </a:r>
                     </a:p>
                   </a:txBody>
@@ -5980,13 +6517,13 @@
                     <a:p>
                       <a:pPr algn="r"/>
                       <a:r>
-                        <a:rPr sz="1600" b="0" i="0">
+                        <a:rPr sz="1500" b="0" i="0">
                           <a:solidFill>
                             <a:srgbClr val="2B2F36"/>
                           </a:solidFill>
                           <a:latin typeface="Calibri"/>
                         </a:rPr>
-                        <a:t>USD 2,187.62</a:t>
+                        <a:t>$2,187.62</a:t>
                       </a:r>
                     </a:p>
                   </a:txBody>
@@ -6005,7 +6542,7 @@
                     <a:p>
                       <a:pPr algn="l"/>
                       <a:r>
-                        <a:rPr sz="1600" b="0" i="0">
+                        <a:rPr sz="1500" b="0" i="0">
                           <a:solidFill>
                             <a:srgbClr val="2B2F36"/>
                           </a:solidFill>
@@ -6028,13 +6565,13 @@
                     <a:p>
                       <a:pPr algn="l"/>
                       <a:r>
-                        <a:rPr sz="1600" b="0" i="0">
+                        <a:rPr sz="1500" b="0" i="0">
                           <a:solidFill>
                             <a:srgbClr val="2B2F36"/>
                           </a:solidFill>
                           <a:latin typeface="Calibri"/>
                         </a:rPr>
-                        <a:t>2026-10-09</a:t>
+                        <a:t>Oct 9</a:t>
                       </a:r>
                     </a:p>
                   </a:txBody>
@@ -6051,13 +6588,13 @@
                     <a:p>
                       <a:pPr algn="r"/>
                       <a:r>
-                        <a:rPr sz="1600" b="0" i="0">
+                        <a:rPr sz="1500" b="0" i="0">
                           <a:solidFill>
                             <a:srgbClr val="2B2F36"/>
                           </a:solidFill>
                           <a:latin typeface="Calibri"/>
                         </a:rPr>
-                        <a:t>USD 2,016.71</a:t>
+                        <a:t>$2,016.71</a:t>
                       </a:r>
                     </a:p>
                   </a:txBody>
@@ -6076,7 +6613,7 @@
                     <a:p>
                       <a:pPr algn="l"/>
                       <a:r>
-                        <a:rPr sz="1600" b="0" i="0">
+                        <a:rPr sz="1500" b="0" i="0">
                           <a:solidFill>
                             <a:srgbClr val="2B2F36"/>
                           </a:solidFill>
@@ -6099,13 +6636,13 @@
                     <a:p>
                       <a:pPr algn="l"/>
                       <a:r>
-                        <a:rPr sz="1600" b="0" i="0">
+                        <a:rPr sz="1500" b="0" i="0">
                           <a:solidFill>
                             <a:srgbClr val="2B2F36"/>
                           </a:solidFill>
                           <a:latin typeface="Calibri"/>
                         </a:rPr>
-                        <a:t>2026-10-23</a:t>
+                        <a:t>Oct 23</a:t>
                       </a:r>
                     </a:p>
                   </a:txBody>
@@ -6122,13 +6659,13 @@
                     <a:p>
                       <a:pPr algn="r"/>
                       <a:r>
-                        <a:rPr sz="1600" b="0" i="0">
+                        <a:rPr sz="1500" b="0" i="0">
                           <a:solidFill>
                             <a:srgbClr val="2B2F36"/>
                           </a:solidFill>
                           <a:latin typeface="Calibri"/>
                         </a:rPr>
-                        <a:t>USD 1,879.87</a:t>
+                        <a:t>$1,879.87</a:t>
                       </a:r>
                     </a:p>
                   </a:txBody>
@@ -6151,8 +6688,8 @@
         </p:nvSpPr>
         <p:spPr>
           <a:xfrm>
-            <a:off x="548640" y="6355080"/>
-            <a:ext cx="11094415" cy="320040"/>
+            <a:off x="548640" y="5989320"/>
+            <a:ext cx="11094415" cy="731520"/>
           </a:xfrm>
           <a:prstGeom prst="rect">
             <a:avLst/>
@@ -6177,7 +6714,7 @@
                 </a:solidFill>
                 <a:latin typeface="Calibri"/>
               </a:rPr>
-              <a:t>Average order value is gross sales over orders for the month. Buyers per active day is the mean of the daily distinct buyer counts, which cannot be summed across days.</a:t>
+              <a:t>Change % is the change over September's figure, n/a when that was zero. Buyers per active day is the average of each day's distinct buyers, over days with orders. Average order value is gross sales divided by orders.</a:t>
             </a:r>
           </a:p>
         </p:txBody>
@@ -6212,8 +6749,8 @@
         </p:nvSpPr>
         <p:spPr>
           <a:xfrm>
-            <a:off x="548640" y="320040"/>
-            <a:ext cx="11094415" cy="914400"/>
+            <a:off x="548640" y="274320"/>
+            <a:ext cx="11094415" cy="1005840"/>
           </a:xfrm>
         </p:spPr>
         <p:txBody>
@@ -6222,13 +6759,13 @@
           <a:p>
             <a:pPr algn="l"/>
             <a:r>
-              <a:rPr sz="2800" b="1" i="0">
+              <a:rPr sz="2400" b="1" i="0">
                 <a:solidFill>
                   <a:srgbClr val="1F3A5F"/>
                 </a:solidFill>
                 <a:latin typeface="Calibri"/>
               </a:rPr>
-              <a:t>What the numbers say</a:t>
+              <a:t>Refunds moved most, up 27.1% from September (October is missing 2 days)</a:t>
             </a:r>
           </a:p>
         </p:txBody>
@@ -6242,7 +6779,7 @@
         <p:spPr>
           <a:xfrm>
             <a:off x="548640" y="1463040"/>
-            <a:ext cx="11094415" cy="4023360"/>
+            <a:ext cx="11094415" cy="4297680"/>
           </a:xfrm>
           <a:prstGeom prst="rect">
             <a:avLst/>
@@ -6267,7 +6804,7 @@
                 </a:solidFill>
                 <a:latin typeface="Calibri"/>
               </a:rPr>
-              <a:t>Net sales were USD 40,249.02 in October 2026, down 1.8% on September 2026 (USD 40,966.11).</a:t>
+              <a:t>Net sales were $40,249.02 in October, down 1.8% from September ($40,966.11), and October is missing 2 days.</a:t>
             </a:r>
           </a:p>
           <a:p>
@@ -6283,7 +6820,7 @@
                 </a:solidFill>
                 <a:latin typeface="Calibri"/>
               </a:rPr>
-              <a:t>Orders were 607 in October 2026, up 3.1% on September 2026 (589).</a:t>
+              <a:t>Orders were 607 in October, up 3.1% from September (589), and October is missing 2 days.</a:t>
             </a:r>
           </a:p>
           <a:p>
@@ -6299,7 +6836,7 @@
                 </a:solidFill>
                 <a:latin typeface="Calibri"/>
               </a:rPr>
-              <a:t>Average order value was USD 69.81, down 3.6% on September 2026.</a:t>
+              <a:t>Average order value was $69.81 in October, down 3.6% from September ($72.39), and October is missing 2 days.</a:t>
             </a:r>
           </a:p>
           <a:p>
@@ -6315,7 +6852,7 @@
                 </a:solidFill>
                 <a:latin typeface="Calibri"/>
               </a:rPr>
-              <a:t>Refunds were USD 2,125.90.</a:t>
+              <a:t>Refunds were $2,125.90 in October, up 27.1% from September ($1,672.94), and October is missing 2 days.</a:t>
             </a:r>
           </a:p>
           <a:p>
@@ -6331,7 +6868,7 @@
                 </a:solidFill>
                 <a:latin typeface="Calibri"/>
               </a:rPr>
-              <a:t>The best day was 2026-10-31 with net sales of USD 2,187.62.</a:t>
+              <a:t>The biggest move was Refunds, up 27.1% from September, and October is missing 2 days.</a:t>
             </a:r>
           </a:p>
           <a:p>
@@ -6347,7 +6884,23 @@
                 </a:solidFill>
                 <a:latin typeface="Calibri"/>
               </a:rPr>
-              <a:t>2 days have no data (2026-10-14, 2026-10-15), so the totals are understated.</a:t>
+              <a:t>The best day was Oct 31 with net sales of $2,187.62.</a:t>
+            </a:r>
+          </a:p>
+          <a:p>
+            <a:pPr>
+              <a:spcAft>
+                <a:spcPts val="1200"/>
+              </a:spcAft>
+            </a:pPr>
+            <a:r>
+              <a:rPr sz="2000" b="0" i="0">
+                <a:solidFill>
+                  <a:srgbClr val="2B2F36"/>
+                </a:solidFill>
+                <a:latin typeface="Calibri"/>
+              </a:rPr>
+              <a:t>2 days have no data (Oct 14, Oct 15), so the totals are understated.</a:t>
             </a:r>
           </a:p>
         </p:txBody>
@@ -6360,8 +6913,8 @@
         </p:nvSpPr>
         <p:spPr>
           <a:xfrm>
-            <a:off x="548640" y="5760720"/>
-            <a:ext cx="11094415" cy="548640"/>
+            <a:off x="548640" y="5989320"/>
+            <a:ext cx="11094415" cy="731520"/>
           </a:xfrm>
           <a:prstGeom prst="rect">
             <a:avLst/>
@@ -6380,13 +6933,13 @@
               </a:spcAft>
             </a:pPr>
             <a:r>
-              <a:rPr sz="1300" b="0" i="1">
+              <a:rPr sz="1100" b="0" i="0">
                 <a:solidFill>
                   <a:srgbClr val="5B6470"/>
                 </a:solidFill>
                 <a:latin typeface="Calibri"/>
               </a:rPr>
-              <a:t>Written by a fixed template from the computed figures (no model key is set). No model was used.</a:t>
+              <a:t>Narrative written from the computed figures on the previous slides.</a:t>
             </a:r>
           </a:p>
         </p:txBody>
@@ -6421,8 +6974,8 @@
         </p:nvSpPr>
         <p:spPr>
           <a:xfrm>
-            <a:off x="548640" y="320040"/>
-            <a:ext cx="11094415" cy="914400"/>
+            <a:off x="548640" y="274320"/>
+            <a:ext cx="11094415" cy="1005840"/>
           </a:xfrm>
         </p:spPr>
         <p:txBody>
@@ -6437,7 +6990,7 @@
                 </a:solidFill>
                 <a:latin typeface="Calibri"/>
               </a:rPr>
-              <a:t>Data health: 28 of 31 days have data in October 2026</a:t>
+              <a:t>Data health: October is missing 2 of 31 days</a:t>
             </a:r>
           </a:p>
         </p:txBody>
@@ -6472,6 +7025,15 @@
                     <a:lstStyle/>
                     <a:p>
                       <a:pPr algn="l"/>
+                      <a:r>
+                        <a:rPr sz="1500" b="1" i="0">
+                          <a:solidFill>
+                            <a:srgbClr val="FFFFFF"/>
+                          </a:solidFill>
+                          <a:latin typeface="Calibri"/>
+                        </a:rPr>
+                        <a:t>Count</a:t>
+                      </a:r>
                     </a:p>
                   </a:txBody>
                   <a:tcPr anchor="ctr">
@@ -6541,7 +7103,7 @@
                           </a:solidFill>
                           <a:latin typeface="Calibri"/>
                         </a:rPr>
-                        <a:t>Days expected</a:t>
+                        <a:t>Days in the month</a:t>
                       </a:r>
                     </a:p>
                   </a:txBody>
@@ -6612,7 +7174,7 @@
                           </a:solidFill>
                           <a:latin typeface="Calibri"/>
                         </a:rPr>
-                        <a:t>Days with snapshots</a:t>
+                        <a:t>Days with orders</a:t>
                       </a:r>
                     </a:p>
                   </a:txBody>
@@ -6683,7 +7245,7 @@
                           </a:solidFill>
                           <a:latin typeface="Calibri"/>
                         </a:rPr>
-                        <a:t>Days with no orders (a sync ran)</a:t>
+                        <a:t>Days with no orders</a:t>
                       </a:r>
                     </a:p>
                   </a:txBody>
@@ -6754,7 +7316,7 @@
                           </a:solidFill>
                           <a:latin typeface="Calibri"/>
                         </a:rPr>
-                        <a:t>Days missing (no snapshot, no sync)</a:t>
+                        <a:t>Days with no data</a:t>
                       </a:r>
                     </a:p>
                   </a:txBody>
@@ -6825,7 +7387,7 @@
                           </a:solidFill>
                           <a:latin typeface="Calibri"/>
                         </a:rPr>
-                        <a:t>Snapshot rows used</a:t>
+                        <a:t>Stored daily figures used</a:t>
                       </a:r>
                     </a:p>
                   </a:txBody>
@@ -6896,7 +7458,7 @@
                           </a:solidFill>
                           <a:latin typeface="Calibri"/>
                         </a:rPr>
-                        <a:t>First and last day with data</a:t>
+                        <a:t>First and last day with orders</a:t>
                       </a:r>
                     </a:p>
                   </a:txBody>
@@ -6919,7 +7481,7 @@
                           </a:solidFill>
                           <a:latin typeface="Calibri"/>
                         </a:rPr>
-                        <a:t>2026-10-01 to 2026-10-31</a:t>
+                        <a:t>Oct 1 to Oct 31</a:t>
                       </a:r>
                     </a:p>
                   </a:txBody>
@@ -6942,7 +7504,7 @@
                           </a:solidFill>
                           <a:latin typeface="Calibri"/>
                         </a:rPr>
-                        <a:t>2026-09-01 to 2026-09-30</a:t>
+                        <a:t>Sep 1 to Sep 30</a:t>
                       </a:r>
                     </a:p>
                   </a:txBody>
@@ -6965,8 +7527,8 @@
         </p:nvSpPr>
         <p:spPr>
           <a:xfrm>
-            <a:off x="548640" y="4572000"/>
-            <a:ext cx="11094415" cy="1645920"/>
+            <a:off x="548640" y="4526280"/>
+            <a:ext cx="11094415" cy="1463040"/>
           </a:xfrm>
           <a:prstGeom prst="rect">
             <a:avLst/>
@@ -6991,7 +7553,7 @@
                 </a:solidFill>
                 <a:latin typeface="Calibri"/>
               </a:rPr>
-              <a:t>Missing days in October 2026: 2026-10-14, 2026-10-15.</a:t>
+              <a:t>Days with no data in October: Oct 14, Oct 15.</a:t>
             </a:r>
           </a:p>
           <a:p>
@@ -7007,7 +7569,7 @@
                 </a:solidFill>
                 <a:latin typeface="Calibri"/>
               </a:rPr>
-              <a:t>Missing days in September 2026: none.</a:t>
+              <a:t>Days with no data in September: none.</a:t>
             </a:r>
           </a:p>
           <a:p>
@@ -7023,7 +7585,7 @@
                 </a:solidFill>
                 <a:latin typeface="Calibri"/>
               </a:rPr>
-              <a:t>Totals for a month with missing days are understated, so its changes are marked partial data.</a:t>
+              <a:t>A month with days missing is understated, so its changes are marked partial.</a:t>
             </a:r>
           </a:p>
         </p:txBody>
@@ -7036,8 +7598,8 @@
         </p:nvSpPr>
         <p:spPr>
           <a:xfrm>
-            <a:off x="548640" y="6355080"/>
-            <a:ext cx="11094415" cy="320040"/>
+            <a:off x="548640" y="5989320"/>
+            <a:ext cx="11094415" cy="731520"/>
           </a:xfrm>
           <a:prstGeom prst="rect">
             <a:avLst/>
@@ -7062,7 +7624,23 @@
                 </a:solidFill>
                 <a:latin typeface="Calibri"/>
               </a:rPr>
-              <a:t>A day counts as a quiet day only when a succeeded or partial sync run's window covers it.</a:t>
+              <a:t>Days with orders, days with no orders and days with no data add up to the days in the month.</a:t>
+            </a:r>
+          </a:p>
+          <a:p>
+            <a:pPr>
+              <a:spcAft>
+                <a:spcPts val="0"/>
+              </a:spcAft>
+            </a:pPr>
+            <a:r>
+              <a:rPr sz="1100" b="0" i="0">
+                <a:solidFill>
+                  <a:srgbClr val="5B6470"/>
+                </a:solidFill>
+                <a:latin typeface="Calibri"/>
+              </a:rPr>
+              <a:t>A day with no orders is one where a data pull ran and found none. A day with no data is one no data pull covered.</a:t>
             </a:r>
           </a:p>
         </p:txBody>

</xml_diff>

<commit_message>
Rebuild the sample deck and make the run steps, counts and limits match what was run
The README now shows the venv and migration steps for each platform without claiming ones that were not run, says the mutation harness edits source in place, and cites the commit that recorded the earlier full run instead of pointing at a file that does not hold it. The known limits of the figure check are written down and pinned by tests.
</commit_message>
<xml_diff>
--- a/docs/monthly-report-sample/report_2026-10.pptx
+++ b/docs/monthly-report-sample/report_2026-10.pptx
@@ -386,6 +386,40 @@
           <c:marker>
             <c:symbol val="none"/>
           </c:marker>
+          <c:dPt>
+            <c:idx val="6"/>
+            <c:marker>
+              <c:symbol val="circle"/>
+              <c:size val="9"/>
+              <c:spPr>
+                <a:solidFill>
+                  <a:srgbClr val="8A94A0"/>
+                </a:solidFill>
+                <a:ln>
+                  <a:solidFill>
+                    <a:srgbClr val="8A94A0"/>
+                  </a:solidFill>
+                </a:ln>
+              </c:spPr>
+            </c:marker>
+          </c:dPt>
+          <c:dPt>
+            <c:idx val="21"/>
+            <c:marker>
+              <c:symbol val="circle"/>
+              <c:size val="9"/>
+              <c:spPr>
+                <a:solidFill>
+                  <a:srgbClr val="8A94A0"/>
+                </a:solidFill>
+                <a:ln>
+                  <a:solidFill>
+                    <a:srgbClr val="8A94A0"/>
+                  </a:solidFill>
+                </a:ln>
+              </c:spPr>
+            </c:marker>
+          </c:dPt>
           <c:cat>
             <c:strRef>
               <c:f>Sheet1!$A$2:$A$32</c:f>
@@ -4479,7 +4513,7 @@
                 </a:solidFill>
                 <a:latin typeface="Calibri"/>
               </a:rPr>
-              <a:t>Net sales fell 1.8% from September (October is missing 2 days)</a:t>
+              <a:t>October net sales total is 1.8% below September, but October is missing 2 days: per reported day it is up 1.6%</a:t>
             </a:r>
           </a:p>
         </p:txBody>
@@ -4779,7 +4813,7 @@
                           </a:solidFill>
                           <a:latin typeface="Calibri"/>
                         </a:rPr>
-                        <a:t>October partial: 2 days missing</a:t>
+                        <a:t>October partial: 2 days missing; per reported day up 6.6%</a:t>
                       </a:r>
                     </a:p>
                   </a:txBody>
@@ -4919,7 +4953,7 @@
                           </a:solidFill>
                           <a:latin typeface="Calibri"/>
                         </a:rPr>
-                        <a:t>October partial: 2 days missing</a:t>
+                        <a:t>October partial: 2 days missing; per reported day up 2.8%</a:t>
                       </a:r>
                     </a:p>
                   </a:txBody>
@@ -5059,7 +5093,7 @@
                           </a:solidFill>
                           <a:latin typeface="Calibri"/>
                         </a:rPr>
-                        <a:t>October partial: 2 days missing</a:t>
+                        <a:t>October partial: 2 days missing; per reported day up 31.5%</a:t>
                       </a:r>
                     </a:p>
                   </a:txBody>
@@ -5199,7 +5233,7 @@
                           </a:solidFill>
                           <a:latin typeface="Calibri"/>
                         </a:rPr>
-                        <a:t>October partial: 2 days missing</a:t>
+                        <a:t>October partial: 2 days missing; per reported day up 1.6%</a:t>
                       </a:r>
                     </a:p>
                   </a:txBody>
@@ -5545,6 +5579,22 @@
                 <a:latin typeface="Calibri"/>
               </a:rPr>
               <a:t>Change % is the change over September's figure, n/a when that was zero. Buyers per active day is the average of each day's distinct buyers, over days with orders. Average order value is gross sales divided by orders.</a:t>
+            </a:r>
+          </a:p>
+          <a:p>
+            <a:pPr>
+              <a:spcAft>
+                <a:spcPts val="0"/>
+              </a:spcAft>
+            </a:pPr>
+            <a:r>
+              <a:rPr sz="1100" b="0" i="0">
+                <a:solidFill>
+                  <a:srgbClr val="5B6470"/>
+                </a:solidFill>
+                <a:latin typeface="Calibri"/>
+              </a:rPr>
+              <a:t>Per reported day divides a total by the days with orders plus the days with no orders, so months with different numbers of days with data can be compared.</a:t>
             </a:r>
           </a:p>
         </p:txBody>
@@ -5668,7 +5718,7 @@
                 </a:solidFill>
                 <a:latin typeface="Calibri"/>
               </a:rPr>
-              <a:t>A dot on the zero line is a day with no orders.</a:t>
+              <a:t>A dot on the zero line is a day with no orders, on either line.</a:t>
             </a:r>
           </a:p>
           <a:p>
@@ -5808,7 +5858,7 @@
                 </a:solidFill>
                 <a:latin typeface="Calibri"/>
               </a:rPr>
-              <a:t>A dot on the zero line is a day with no orders.</a:t>
+              <a:t>A dot on the zero line is a day with no orders, on either line.</a:t>
             </a:r>
           </a:p>
           <a:p>
@@ -6765,7 +6815,7 @@
                 </a:solidFill>
                 <a:latin typeface="Calibri"/>
               </a:rPr>
-              <a:t>Refunds moved most, up 27.1% from September (October is missing 2 days)</a:t>
+              <a:t>October refunds total is 27.1% above September, but October is missing 2 days: per reported day it is up 31.5%</a:t>
             </a:r>
           </a:p>
         </p:txBody>
@@ -6779,7 +6829,7 @@
         <p:spPr>
           <a:xfrm>
             <a:off x="548640" y="1463040"/>
-            <a:ext cx="11094415" cy="4297680"/>
+            <a:ext cx="11094415" cy="4389120"/>
           </a:xfrm>
           <a:prstGeom prst="rect">
             <a:avLst/>
@@ -6794,43 +6844,43 @@
           <a:p>
             <a:pPr>
               <a:spcAft>
-                <a:spcPts val="1200"/>
+                <a:spcPts val="800"/>
               </a:spcAft>
             </a:pPr>
             <a:r>
-              <a:rPr sz="2000" b="0" i="0">
+              <a:rPr sz="1800" b="0" i="0">
                 <a:solidFill>
                   <a:srgbClr val="2B2F36"/>
                 </a:solidFill>
                 <a:latin typeface="Calibri"/>
               </a:rPr>
-              <a:t>Net sales were $40,249.02 in October, down 1.8% from September ($40,966.11), and October is missing 2 days.</a:t>
+              <a:t>Net sales total was $40,249.02 in October, 1.8% below September ($40,966.11), but October is missing 2 days: per reported day, net sales are up 1.6% ($1,387.90 against $1,365.54).</a:t>
             </a:r>
           </a:p>
           <a:p>
             <a:pPr>
               <a:spcAft>
-                <a:spcPts val="1200"/>
+                <a:spcPts val="800"/>
               </a:spcAft>
             </a:pPr>
             <a:r>
-              <a:rPr sz="2000" b="0" i="0">
+              <a:rPr sz="1800" b="0" i="0">
                 <a:solidFill>
                   <a:srgbClr val="2B2F36"/>
                 </a:solidFill>
                 <a:latin typeface="Calibri"/>
               </a:rPr>
-              <a:t>Orders were 607 in October, up 3.1% from September (589), and October is missing 2 days.</a:t>
+              <a:t>Orders total was 607 in October, 3.1% above September (589), but October is missing 2 days: per reported day, orders are up 6.6% (20.93 against 19.63).</a:t>
             </a:r>
           </a:p>
           <a:p>
             <a:pPr>
               <a:spcAft>
-                <a:spcPts val="1200"/>
+                <a:spcPts val="800"/>
               </a:spcAft>
             </a:pPr>
             <a:r>
-              <a:rPr sz="2000" b="0" i="0">
+              <a:rPr sz="1800" b="0" i="0">
                 <a:solidFill>
                   <a:srgbClr val="2B2F36"/>
                 </a:solidFill>
@@ -6842,43 +6892,43 @@
           <a:p>
             <a:pPr>
               <a:spcAft>
-                <a:spcPts val="1200"/>
+                <a:spcPts val="800"/>
               </a:spcAft>
             </a:pPr>
             <a:r>
-              <a:rPr sz="2000" b="0" i="0">
+              <a:rPr sz="1800" b="0" i="0">
                 <a:solidFill>
                   <a:srgbClr val="2B2F36"/>
                 </a:solidFill>
                 <a:latin typeface="Calibri"/>
               </a:rPr>
-              <a:t>Refunds were $2,125.90 in October, up 27.1% from September ($1,672.94), and October is missing 2 days.</a:t>
+              <a:t>Refunds total was $2,125.90 in October, 27.1% above September ($1,672.94), but October is missing 2 days: per reported day, refunds are up 31.5% ($73.31 against $55.76).</a:t>
             </a:r>
           </a:p>
           <a:p>
             <a:pPr>
               <a:spcAft>
-                <a:spcPts val="1200"/>
+                <a:spcPts val="800"/>
               </a:spcAft>
             </a:pPr>
             <a:r>
-              <a:rPr sz="2000" b="0" i="0">
+              <a:rPr sz="1800" b="0" i="0">
                 <a:solidFill>
                   <a:srgbClr val="2B2F36"/>
                 </a:solidFill>
                 <a:latin typeface="Calibri"/>
               </a:rPr>
-              <a:t>The biggest move was Refunds, up 27.1% from September, and October is missing 2 days.</a:t>
+              <a:t>The biggest move was Refunds, 27.1% above September in total, but October is missing 2 days: per reported day it is up 31.5%.</a:t>
             </a:r>
           </a:p>
           <a:p>
             <a:pPr>
               <a:spcAft>
-                <a:spcPts val="1200"/>
+                <a:spcPts val="800"/>
               </a:spcAft>
             </a:pPr>
             <a:r>
-              <a:rPr sz="2000" b="0" i="0">
+              <a:rPr sz="1800" b="0" i="0">
                 <a:solidFill>
                   <a:srgbClr val="2B2F36"/>
                 </a:solidFill>
@@ -6890,11 +6940,11 @@
           <a:p>
             <a:pPr>
               <a:spcAft>
-                <a:spcPts val="1200"/>
+                <a:spcPts val="800"/>
               </a:spcAft>
             </a:pPr>
             <a:r>
-              <a:rPr sz="2000" b="0" i="0">
+              <a:rPr sz="1800" b="0" i="0">
                 <a:solidFill>
                   <a:srgbClr val="2B2F36"/>
                 </a:solidFill>

</xml_diff>